<commit_message>
feat(qcc-method-compliant): v5.1 method logic gates
- verify Pareto data (descending, total=sample, cumulative to 100%, 80% focus coverage)
- recompute target direction/formula and effect attainment/progress; require post period+sample
- require true-cause sample >=30 or an explicit sampling basis
- match steps by slide title; ignore page badges and footer chrome in numeric extraction
- fix fishbone terminology to 5M1E/6M
- add method-theater fixture and assert it is rejected
</commit_message>
<xml_diff>
--- a/skills/qcc-ppt-method-compliant-producer/examples/fixtures/data-complete.qcc.pptx
+++ b/skills/qcc-ppt-method-compliant-producer/examples/fixtures/data-complete.qcc.pptx
@@ -4232,7 +4232,15 @@
               <a:defRPr sz="1400"/>
             </a:pPr>
             <a:r>
-              <a:t>目标达成率：102.2%；进步率：67.6%。</a:t>
+              <a:t>目标达成率：99.0%；进步率：67.6%。</a:t>
+            </a:r>
+          </a:p>
+          <a:p>
+            <a:pPr>
+              <a:defRPr sz="1400"/>
+            </a:pPr>
+            <a:r>
+              <a:t>改善后收集期间：2026-03-01 ~ 03-31；样本量：300 例。</a:t>
             </a:r>
           </a:p>
           <a:p>
@@ -5162,7 +5170,7 @@
               <a:defRPr sz="1400"/>
             </a:pPr>
             <a:r>
-              <a:t>类别与频次：校验异常 126，记录缺失 58，流程等待 42，标注错误 30，其他 44。</a:t>
+              <a:t>类别与频次：校验异常 126，记录缺失 70，流程等待 60，标注错误 30，其他 14。</a:t>
             </a:r>
           </a:p>
         </p:txBody>
@@ -5216,7 +5224,7 @@
         </p:nvGraphicFramePr>
         <p:xfrm>
           <a:off x="457200" y="1371600"/>
-          <a:ext cx="8229600" cy="1828800"/>
+          <a:ext cx="8229600" cy="2194560"/>
         </p:xfrm>
         <a:graphic>
           <a:graphicData uri="http://schemas.openxmlformats.org/drawingml/2006/table">
@@ -5349,31 +5357,31 @@
                     <a:lstStyle/>
                     <a:p>
                       <a:r>
-                        <a:t>58</a:t>
-                      </a:r>
-                    </a:p>
-                  </a:txBody>
-                  <a:tcPr/>
-                </a:tc>
-                <a:tc>
-                  <a:txBody>
-                    <a:bodyPr/>
-                    <a:lstStyle/>
-                    <a:p>
-                      <a:r>
-                        <a:t>19.3%</a:t>
-                      </a:r>
-                    </a:p>
-                  </a:txBody>
-                  <a:tcPr/>
-                </a:tc>
-                <a:tc>
-                  <a:txBody>
-                    <a:bodyPr/>
-                    <a:lstStyle/>
-                    <a:p>
-                      <a:r>
-                        <a:t>61.3%</a:t>
+                        <a:t>70</a:t>
+                      </a:r>
+                    </a:p>
+                  </a:txBody>
+                  <a:tcPr/>
+                </a:tc>
+                <a:tc>
+                  <a:txBody>
+                    <a:bodyPr/>
+                    <a:lstStyle/>
+                    <a:p>
+                      <a:r>
+                        <a:t>23.3%</a:t>
+                      </a:r>
+                    </a:p>
+                  </a:txBody>
+                  <a:tcPr/>
+                </a:tc>
+                <a:tc>
+                  <a:txBody>
+                    <a:bodyPr/>
+                    <a:lstStyle/>
+                    <a:p>
+                      <a:r>
+                        <a:t>65.3%</a:t>
                       </a:r>
                     </a:p>
                   </a:txBody>
@@ -5399,31 +5407,31 @@
                     <a:lstStyle/>
                     <a:p>
                       <a:r>
-                        <a:t>42</a:t>
-                      </a:r>
-                    </a:p>
-                  </a:txBody>
-                  <a:tcPr/>
-                </a:tc>
-                <a:tc>
-                  <a:txBody>
-                    <a:bodyPr/>
-                    <a:lstStyle/>
-                    <a:p>
-                      <a:r>
-                        <a:t>14.0%</a:t>
-                      </a:r>
-                    </a:p>
-                  </a:txBody>
-                  <a:tcPr/>
-                </a:tc>
-                <a:tc>
-                  <a:txBody>
-                    <a:bodyPr/>
-                    <a:lstStyle/>
-                    <a:p>
-                      <a:r>
-                        <a:t>75.3%</a:t>
+                        <a:t>60</a:t>
+                      </a:r>
+                    </a:p>
+                  </a:txBody>
+                  <a:tcPr/>
+                </a:tc>
+                <a:tc>
+                  <a:txBody>
+                    <a:bodyPr/>
+                    <a:lstStyle/>
+                    <a:p>
+                      <a:r>
+                        <a:t>20.0%</a:t>
+                      </a:r>
+                    </a:p>
+                  </a:txBody>
+                  <a:tcPr/>
+                </a:tc>
+                <a:tc>
+                  <a:txBody>
+                    <a:bodyPr/>
+                    <a:lstStyle/>
+                    <a:p>
+                      <a:r>
+                        <a:t>85.3%</a:t>
                       </a:r>
                     </a:p>
                   </a:txBody>
@@ -5473,7 +5481,57 @@
                     <a:lstStyle/>
                     <a:p>
                       <a:r>
-                        <a:t>85.3%</a:t>
+                        <a:t>95.3%</a:t>
+                      </a:r>
+                    </a:p>
+                  </a:txBody>
+                  <a:tcPr/>
+                </a:tc>
+              </a:tr>
+              <a:tr h="365760">
+                <a:tc>
+                  <a:txBody>
+                    <a:bodyPr/>
+                    <a:lstStyle/>
+                    <a:p>
+                      <a:r>
+                        <a:t>其他</a:t>
+                      </a:r>
+                    </a:p>
+                  </a:txBody>
+                  <a:tcPr/>
+                </a:tc>
+                <a:tc>
+                  <a:txBody>
+                    <a:bodyPr/>
+                    <a:lstStyle/>
+                    <a:p>
+                      <a:r>
+                        <a:t>14</a:t>
+                      </a:r>
+                    </a:p>
+                  </a:txBody>
+                  <a:tcPr/>
+                </a:tc>
+                <a:tc>
+                  <a:txBody>
+                    <a:bodyPr/>
+                    <a:lstStyle/>
+                    <a:p>
+                      <a:r>
+                        <a:t>4.7%</a:t>
+                      </a:r>
+                    </a:p>
+                  </a:txBody>
+                  <a:tcPr/>
+                </a:tc>
+                <a:tc>
+                  <a:txBody>
+                    <a:bodyPr/>
+                    <a:lstStyle/>
+                    <a:p>
+                      <a:r>
+                        <a:t>100.0%</a:t>
                       </a:r>
                     </a:p>
                   </a:txBody>
@@ -5577,7 +5635,7 @@
               <a:defRPr sz="1400"/>
             </a:pPr>
             <a:r>
-              <a:t>问题类别按频次降序排列：校验异常 126、记录缺失 58、流程等待 42、标注错误 30、其他 44。</a:t>
+              <a:t>问题类别按频次降序排列：校验异常 126、记录缺失 70、流程等待 60、标注错误 30、其他 14。</a:t>
             </a:r>
           </a:p>
           <a:p>
@@ -5585,7 +5643,7 @@
               <a:defRPr sz="1400"/>
             </a:pPr>
             <a:r>
-              <a:t>累计百分比：42.0% / 61.3% / 75.3% / 85.3% / 100.0%。</a:t>
+              <a:t>累计百分比：42.0% / 65.3% / 85.3% / 95.3% / 100.0%。</a:t>
             </a:r>
           </a:p>
           <a:p>

</xml_diff>

<commit_message>
feat(qcc-method-compliant): v5.2 extended gates and cross-step consistency
- theme: require evaluation rule (weight/rating criteria)
- plan: require plan-vs-actual progress evidence
- check sheet: require collection method and owner
- intangible results: require scale, dimensions and before/after means
- standardization: require document number/version/effective date and audit write-back
- add cross-step check (step 11): every adopted countermeasure maps to a verified cause
- update fixtures and docs
</commit_message>
<xml_diff>
--- a/skills/qcc-ppt-method-compliant-producer/examples/fixtures/data-complete.qcc.pptx
+++ b/skills/qcc-ppt-method-compliant-producer/examples/fixtures/data-complete.qcc.pptx
@@ -3298,16 +3298,293 @@
           </a:p>
         </p:txBody>
       </p:sp>
-      <p:sp>
-        <p:nvSpPr>
-          <p:cNvPr id="3" name="TextBox 2"/>
+      <p:graphicFrame>
+        <p:nvGraphicFramePr>
+          <p:cNvPr id="3" name="Table 2"/>
+          <p:cNvGraphicFramePr>
+            <a:graphicFrameLocks noGrp="1"/>
+          </p:cNvGraphicFramePr>
+          <p:nvPr/>
+        </p:nvGraphicFramePr>
+        <p:xfrm>
+          <a:off x="457200" y="1371600"/>
+          <a:ext cx="8229600" cy="1463040"/>
+        </p:xfrm>
+        <a:graphic>
+          <a:graphicData uri="http://schemas.openxmlformats.org/drawingml/2006/table">
+            <a:tbl>
+              <a:tblPr firstRow="1" bandRow="1">
+                <a:tableStyleId>{5C22544A-7EE6-4342-B048-85BDC9FD1C3A}</a:tableStyleId>
+              </a:tblPr>
+              <a:tblGrid>
+                <a:gridCol w="1645920"/>
+                <a:gridCol w="1645920"/>
+                <a:gridCol w="1645920"/>
+                <a:gridCol w="1645920"/>
+                <a:gridCol w="1645920"/>
+              </a:tblGrid>
+              <a:tr h="365760">
+                <a:tc>
+                  <a:txBody>
+                    <a:bodyPr/>
+                    <a:lstStyle/>
+                    <a:p>
+                      <a:r>
+                        <a:t>要因</a:t>
+                      </a:r>
+                    </a:p>
+                  </a:txBody>
+                  <a:tcPr/>
+                </a:tc>
+                <a:tc>
+                  <a:txBody>
+                    <a:bodyPr/>
+                    <a:lstStyle/>
+                    <a:p>
+                      <a:r>
+                        <a:t>数据来源</a:t>
+                      </a:r>
+                    </a:p>
+                  </a:txBody>
+                  <a:tcPr/>
+                </a:tc>
+                <a:tc>
+                  <a:txBody>
+                    <a:bodyPr/>
+                    <a:lstStyle/>
+                    <a:p>
+                      <a:r>
+                        <a:t>验证方法</a:t>
+                      </a:r>
+                    </a:p>
+                  </a:txBody>
+                  <a:tcPr/>
+                </a:tc>
+                <a:tc>
+                  <a:txBody>
+                    <a:bodyPr/>
+                    <a:lstStyle/>
+                    <a:p>
+                      <a:r>
+                        <a:t>验证结果</a:t>
+                      </a:r>
+                    </a:p>
+                  </a:txBody>
+                  <a:tcPr/>
+                </a:tc>
+                <a:tc>
+                  <a:txBody>
+                    <a:bodyPr/>
+                    <a:lstStyle/>
+                    <a:p>
+                      <a:r>
+                        <a:t>结论</a:t>
+                      </a:r>
+                    </a:p>
+                  </a:txBody>
+                  <a:tcPr/>
+                </a:tc>
+              </a:tr>
+              <a:tr h="365760">
+                <a:tc>
+                  <a:txBody>
+                    <a:bodyPr/>
+                    <a:lstStyle/>
+                    <a:p>
+                      <a:r>
+                        <a:t>校验规则缺失</a:t>
+                      </a:r>
+                    </a:p>
+                  </a:txBody>
+                  <a:tcPr/>
+                </a:tc>
+                <a:tc>
+                  <a:txBody>
+                    <a:bodyPr/>
+                    <a:lstStyle/>
+                    <a:p>
+                      <a:r>
+                        <a:t>查检表 300 例 + 现场记录</a:t>
+                      </a:r>
+                    </a:p>
+                  </a:txBody>
+                  <a:tcPr/>
+                </a:tc>
+                <a:tc>
+                  <a:txBody>
+                    <a:bodyPr/>
+                    <a:lstStyle/>
+                    <a:p>
+                      <a:r>
+                        <a:t>按规则缺失分类统计</a:t>
+                      </a:r>
+                    </a:p>
+                  </a:txBody>
+                  <a:tcPr/>
+                </a:tc>
+                <a:tc>
+                  <a:txBody>
+                    <a:bodyPr/>
+                    <a:lstStyle/>
+                    <a:p>
+                      <a:r>
+                        <a:t>关联异常 98 例（77.8%）</a:t>
+                      </a:r>
+                    </a:p>
+                  </a:txBody>
+                  <a:tcPr/>
+                </a:tc>
+                <a:tc>
+                  <a:txBody>
+                    <a:bodyPr/>
+                    <a:lstStyle/>
+                    <a:p>
+                      <a:r>
+                        <a:t>真因成立</a:t>
+                      </a:r>
+                    </a:p>
+                  </a:txBody>
+                  <a:tcPr/>
+                </a:tc>
+              </a:tr>
+              <a:tr h="365760">
+                <a:tc>
+                  <a:txBody>
+                    <a:bodyPr/>
+                    <a:lstStyle/>
+                    <a:p>
+                      <a:r>
+                        <a:t>字段定义不统一</a:t>
+                      </a:r>
+                    </a:p>
+                  </a:txBody>
+                  <a:tcPr/>
+                </a:tc>
+                <a:tc>
+                  <a:txBody>
+                    <a:bodyPr/>
+                    <a:lstStyle/>
+                    <a:p>
+                      <a:r>
+                        <a:t>查检表 300 例 + 字段字典</a:t>
+                      </a:r>
+                    </a:p>
+                  </a:txBody>
+                  <a:tcPr/>
+                </a:tc>
+                <a:tc>
+                  <a:txBody>
+                    <a:bodyPr/>
+                    <a:lstStyle/>
+                    <a:p>
+                      <a:r>
+                        <a:t>对比字段口径差异</a:t>
+                      </a:r>
+                    </a:p>
+                  </a:txBody>
+                  <a:tcPr/>
+                </a:tc>
+                <a:tc>
+                  <a:txBody>
+                    <a:bodyPr/>
+                    <a:lstStyle/>
+                    <a:p>
+                      <a:r>
+                        <a:t>关联异常 36 例（28.6%）</a:t>
+                      </a:r>
+                    </a:p>
+                  </a:txBody>
+                  <a:tcPr/>
+                </a:tc>
+                <a:tc>
+                  <a:txBody>
+                    <a:bodyPr/>
+                    <a:lstStyle/>
+                    <a:p>
+                      <a:r>
+                        <a:t>真因成立</a:t>
+                      </a:r>
+                    </a:p>
+                  </a:txBody>
+                  <a:tcPr/>
+                </a:tc>
+              </a:tr>
+              <a:tr h="365760">
+                <a:tc>
+                  <a:txBody>
+                    <a:bodyPr/>
+                    <a:lstStyle/>
+                    <a:p>
+                      <a:r>
+                        <a:t>抽样标准不明确</a:t>
+                      </a:r>
+                    </a:p>
+                  </a:txBody>
+                  <a:tcPr/>
+                </a:tc>
+                <a:tc>
+                  <a:txBody>
+                    <a:bodyPr/>
+                    <a:lstStyle/>
+                    <a:p>
+                      <a:r>
+                        <a:t>抽检记录 60 例</a:t>
+                      </a:r>
+                    </a:p>
+                  </a:txBody>
+                  <a:tcPr/>
+                </a:tc>
+                <a:tc>
+                  <a:txBody>
+                    <a:bodyPr/>
+                    <a:lstStyle/>
+                    <a:p>
+                      <a:r>
+                        <a:t>重抽对比判定差异</a:t>
+                      </a:r>
+                    </a:p>
+                  </a:txBody>
+                  <a:tcPr/>
+                </a:tc>
+                <a:tc>
+                  <a:txBody>
+                    <a:bodyPr/>
+                    <a:lstStyle/>
+                    <a:p>
+                      <a:r>
+                        <a:t>差异 &lt; 5%，不显著</a:t>
+                      </a:r>
+                    </a:p>
+                  </a:txBody>
+                  <a:tcPr/>
+                </a:tc>
+                <a:tc>
+                  <a:txBody>
+                    <a:bodyPr/>
+                    <a:lstStyle/>
+                    <a:p>
+                      <a:r>
+                        <a:t>不成立，回退</a:t>
+                      </a:r>
+                    </a:p>
+                  </a:txBody>
+                  <a:tcPr/>
+                </a:tc>
+              </a:tr>
+            </a:tbl>
+          </a:graphicData>
+        </a:graphic>
+      </p:graphicFrame>
+      <p:sp>
+        <p:nvSpPr>
+          <p:cNvPr id="4" name="TextBox 3"/>
           <p:cNvSpPr txBox="1"/>
           <p:nvPr/>
         </p:nvSpPr>
         <p:spPr>
           <a:xfrm>
-            <a:off x="548640" y="1463040"/>
-            <a:ext cx="8229600" cy="4206240"/>
+            <a:off x="457200" y="3840480"/>
+            <a:ext cx="8229600" cy="1828800"/>
           </a:xfrm>
           <a:prstGeom prst="rect">
             <a:avLst/>
@@ -3320,35 +3597,8 @@
           </a:bodyPr>
           <a:lstStyle/>
           <a:p>
-            <a:pPr>
-              <a:defRPr sz="1400"/>
-            </a:pPr>
-            <a:r>
-              <a:t>真因验证：要因1 校验规则缺失。数据来源：查检表 300 例 + 现场记录。</a:t>
-            </a:r>
-          </a:p>
-          <a:p>
-            <a:pPr>
-              <a:defRPr sz="1400"/>
-            </a:pPr>
-            <a:r>
-              <a:t>验证方法：对 300 例异常按规则缺失分类统计。</a:t>
-            </a:r>
-          </a:p>
-          <a:p>
-            <a:pPr>
-              <a:defRPr sz="1400"/>
-            </a:pPr>
-            <a:r>
-              <a:t>验证结果：规则缺失关联异常 98 例（占异常 77.8%）。</a:t>
-            </a:r>
-          </a:p>
-          <a:p>
-            <a:pPr>
-              <a:defRPr sz="1400"/>
-            </a:pPr>
-            <a:r>
-              <a:t>结论：成立（真因）；未通过项（抽样标准）回退至下一轮分析。</a:t>
+            <a:r>
+              <a:t>真因验证数据来源、结果与结论齐备；不成立项已回退。</a:t>
             </a:r>
           </a:p>
         </p:txBody>
@@ -4326,6 +4576,14 @@
               <a:defRPr sz="1400"/>
             </a:pPr>
             <a:r>
+              <a:t>评价量表：1–5 分制；维度：问题意识、数据分析、团队协作、表达沟通、工具应用。</a:t>
+            </a:r>
+          </a:p>
+          <a:p>
+            <a:pPr>
+              <a:defRPr sz="1400"/>
+            </a:pPr>
+            <a:r>
               <a:t>圈员能力评分：活动前 3.1 分，活动后 4.2 分。</a:t>
             </a:r>
           </a:p>
@@ -4404,7 +4662,7 @@
               <a:defRPr sz="1400"/>
             </a:pPr>
             <a:r>
-              <a:t>标准化文件名称：《结果校验作业标准书》，编号 QCC-STD-001，类型：作业标准书。</a:t>
+              <a:t>标准化文件名称：《结果校验作业标准书》，编号 QCC-STD-001，版本 V1.0，生效日期 2026-04-01。</a:t>
             </a:r>
           </a:p>
           <a:p>
@@ -4412,7 +4670,7 @@
               <a:defRPr sz="1400"/>
             </a:pPr>
             <a:r>
-              <a:t>日常稽核：责任人张三，每月 1 次，按检查表逐项稽核。</a:t>
+              <a:t>日常稽核：责任人张三，每月 1 次，按检查表逐项稽核；稽核结果回写班组看板。</a:t>
             </a:r>
           </a:p>
           <a:p>
@@ -4421,6 +4679,14 @@
             </a:pPr>
             <a:r>
               <a:t>教育训练与推广：新员工入职培训纳入本标准，向二线班组推广。</a:t>
+            </a:r>
+          </a:p>
+          <a:p>
+            <a:pPr>
+              <a:defRPr sz="1400"/>
+            </a:pPr>
+            <a:r>
+              <a:t>效果维持：连续 3 个月复查达标。</a:t>
             </a:r>
           </a:p>
         </p:txBody>
@@ -4907,6 +5173,11 @@
           <a:lstStyle/>
           <a:p>
             <a:r>
+              <a:t>评价规则：5 分制，圈员独立打分取平均，权重相同。</a:t>
+            </a:r>
+          </a:p>
+          <a:p>
+            <a:r>
               <a:t>排序：1 降低处理异常率，2 缩短处理时长，3 减少返工次数。</a:t>
             </a:r>
           </a:p>
@@ -5001,6 +5272,14 @@
               <a:t>负责人：张三（计划）、李四（实施）、王五（检查）</a:t>
             </a:r>
           </a:p>
+          <a:p>
+            <a:pPr>
+              <a:defRPr sz="1400"/>
+            </a:pPr>
+            <a:r>
+              <a:t>计划 vs 实际：前 4 周按计划完成，第 5 周延期 1 天，完成率 95%。</a:t>
+            </a:r>
+          </a:p>
         </p:txBody>
       </p:sp>
     </p:spTree>
@@ -5163,6 +5442,14 @@
             </a:pPr>
             <a:r>
               <a:t>样本量：300 例。</a:t>
+            </a:r>
+          </a:p>
+          <a:p>
+            <a:pPr>
+              <a:defRPr sz="1400"/>
+            </a:pPr>
+            <a:r>
+              <a:t>收集方法：查检表逐例记录；责任人：李四。</a:t>
             </a:r>
           </a:p>
           <a:p>

</xml_diff>

<commit_message>
feat(qcc-method-compliant): v5.3 tool-selection, statistics and cost-benefit gates
- 现状把握: require data type + tool-selection rationale (tool matrix)
- 效果确认: require a statistical test (method + p value/CI) or an explicit waiver
- 效果确认: require cost-benefit (input, savings, payback/ROI)
- methodology: add tool-selection matrix and statistics/cost-benefit sections
</commit_message>
<xml_diff>
--- a/skills/qcc-ppt-method-compliant-producer/examples/fixtures/data-complete.qcc.pptx
+++ b/skills/qcc-ppt-method-compliant-producer/examples/fixtures/data-complete.qcc.pptx
@@ -4501,6 +4501,22 @@
               <a:t>改善前后对比图（柏拉图）：异常率显著下降。</a:t>
             </a:r>
           </a:p>
+          <a:p>
+            <a:pPr>
+              <a:defRPr sz="1400"/>
+            </a:pPr>
+            <a:r>
+              <a:t>统计检验：χ² 检验，p &lt; 0.05，差异显著。</a:t>
+            </a:r>
+          </a:p>
+          <a:p>
+            <a:pPr>
+              <a:defRPr sz="1400"/>
+            </a:pPr>
+            <a:r>
+              <a:t>效益核算：投入 24 人时（约 0.4 万元），年化节省 312 小时（约 5.2 万元），回收期 &lt; 1 个月。</a:t>
+            </a:r>
+          </a:p>
         </p:txBody>
       </p:sp>
     </p:spTree>
@@ -5450,6 +5466,14 @@
             </a:pPr>
             <a:r>
               <a:t>收集方法：查检表逐例记录；责任人：李四。</a:t>
+            </a:r>
+          </a:p>
+          <a:p>
+            <a:pPr>
+              <a:defRPr sz="1400"/>
+            </a:pPr>
+            <a:r>
+              <a:t>数据类型：计数值（异常例数）；选用查检表 + 柏拉图 + 层别分析。</a:t>
             </a:r>
           </a:p>
           <a:p>

</xml_diff>